<commit_message>
Mentor deck: full speaking script in the notes, load-test and rerun numbers
Co-Authored-By: Claude Sonnet 5.5 <noreply@anthropic.com>
</commit_message>
<xml_diff>
--- a/docs/presentation/ClaimGuard_Mentor_Session.pptx
+++ b/docs/presentation/ClaimGuard_Mentor_Session.pptx
@@ -128,21 +128,21 @@
   <p:extLst>
     <p:ext uri="{521415D9-36F7-43E2-AB2F-B90AF26B5E84}">
       <p14:sectionLst xmlns:p14="http://schemas.microsoft.com/office/powerpoint/2010/main">
-        <p14:section name="Opening" id="{4113cbad-9147-32df-257f-8e2187e82573}">
+        <p14:section name="Opening" id="{3f508a7e-7c3b-bc0d-d765-7ded606fbc0a}">
           <p14:sldIdLst>
             <p14:sldId id="256"/>
             <p14:sldId id="257"/>
             <p14:sldId id="258"/>
           </p14:sldIdLst>
         </p14:section>
-        <p14:section name="Core" id="{87505a97-640c-cc24-54c3-d6e91e1b52b2}">
+        <p14:section name="Core" id="{b6ca45f2-fc9d-e78b-0d45-e599be936ae4}">
           <p14:sldIdLst>
             <p14:sldId id="259"/>
             <p14:sldId id="260"/>
             <p14:sldId id="261"/>
           </p14:sldIdLst>
         </p14:section>
-        <p14:section name="Queue and AI" id="{779255aa-051c-ea2e-c5da-c298c1dc368e}">
+        <p14:section name="Queue and AI" id="{0d883270-65d2-2859-2d82-ab814d89f7f1}">
           <p14:sldIdLst>
             <p14:sldId id="262"/>
             <p14:sldId id="263"/>
@@ -150,21 +150,21 @@
             <p14:sldId id="265"/>
           </p14:sldIdLst>
         </p14:section>
-        <p14:section name="Built this week" id="{b5ea3095-b8a8-db46-2106-e480086701ca}">
+        <p14:section name="Built this week" id="{e5b6fecc-6dd8-54f3-54f8-d0587b5dcbfc}">
           <p14:sldIdLst>
             <p14:sldId id="266"/>
             <p14:sldId id="267"/>
             <p14:sldId id="268"/>
           </p14:sldIdLst>
         </p14:section>
-        <p14:section name="Less work for the operator" id="{76c330c8-3e44-cfda-5e2e-c2a073867424}">
+        <p14:section name="Less work for the operator" id="{aeb841a9-ced8-85b7-049d-db18da55e8c5}">
           <p14:sldIdLst>
             <p14:sldId id="269"/>
             <p14:sldId id="270"/>
             <p14:sldId id="271"/>
           </p14:sldIdLst>
         </p14:section>
-        <p14:section name="Trust" id="{233c570f-2124-2c9c-3922-01749ac6410d}">
+        <p14:section name="Trust" id="{aa79cb90-8088-36b3-f504-7ca9d0c254b0}">
           <p14:sldIdLst>
             <p14:sldId id="272"/>
             <p14:sldId id="273"/>
@@ -172,7 +172,7 @@
             <p14:sldId id="275"/>
           </p14:sldIdLst>
         </p14:section>
-        <p14:section name="Close" id="{3812ea31-f601-64a9-3c17-6a162773f72f}">
+        <p14:section name="Close" id="{927ee377-f915-5085-d43c-40fb63199711}">
           <p14:sldIdLst>
             <p14:sldId id="276"/>
             <p14:sldId id="277"/>
@@ -1231,7 +1231,7 @@
           <a:p>
             <a:r>
               <a:rPr lang="en-US" dirty="0"/>
-              <a:t>Open by saying the goal in the mentor's words: a trustworthy, explainable copilot for claim pre-validation, not a production RCM platform. The deck follows his workflow in section 3.</a:t>
+              <a:t>Good afternoon, and thank you for the email of 16 October. It changed how we spent the week, so I will start from it. The goal you set is a trustworthy, explainable copilot for claim pre-validation, not a production revenue-cycle platform. That is what this deck shows. It covers everything we built after the Phase 1 submission: the rule engine and its checks, the task queue, the cache, the AI explanation step, the new correction workflow, security, audit and deployment. Two promises before we start. Every number you will see comes from a command you can re-run, and anything simulated says so on its own slide. Second, the last two slides list what we have not done, and I will read them out, because you should hear that from us first.</a:t>
             </a:r>
             <a:endParaRPr lang="en-US" dirty="0"/>
           </a:p>
@@ -1319,7 +1319,7 @@
           <a:p>
             <a:r>
               <a:rPr lang="en-US" dirty="0"/>
-              <a:t>Be honest about the AI evaluation: in the supplied-case runs many answers fell back to the template because of provider timeouts. The fallback working is the point, but the live-answer quality sample is small.</a:t>
+              <a:t>Here is how we keep the AI from saying something it should not. First, the model sees only the rule text and never a claim value. Second, its text is checked mechanically: invented values, clinical or fraud talk, approval or payment words, even disguised ones, garbled script and repetition. Third, any failure leaves the engine's own explanation in place: if the model is slow, down, over budget or rejected, the finding and its text stay. Fourth, we red-teamed prompt injection with a real model; it found one hole, we closed it and added a test. In the load test the guard refused templates containing phrases like "have a valid" and "are correct", because the finding did not cover them. That is the guard working. The cost is that a refused template is not cached, so those claims ask the model again. I am honest about the sample: in one twenty-five-case run, seventeen answers fell back to the template.</a:t>
             </a:r>
             <a:endParaRPr lang="en-US" dirty="0"/>
           </a:p>
@@ -1407,7 +1407,7 @@
           <a:p>
             <a:r>
               <a:rPr lang="en-US" dirty="0"/>
-              <a:t>No model here, on purpose. Each sentence is built from the finding and the claim, so every sentence cites a rule and claim paths. That makes grounding something we can test, not hope for.</a:t>
+              <a:t>This is the first of the two things built this week, and it answers your request for correction assistance and a reviewer summary. On the left is the reviewer copilot panel on a real claim. It gives one summary: how many findings, which severity, and the order that clears the claim fastest. It gives one suggestion per finding, of three kinds: a value to correct, a value to check against the source, or information to ask the provider for. We built it with code, on purpose, with no model. Every sentence is built from the finding and the claim, so it cites a rule and claim paths, and that makes grounding something we can test rather than hope for. A value is proposed only if it follows from other values on the same claim, and no identifier can be edited. A claim with no finding reads pre-validation clearance, not payer approval.</a:t>
             </a:r>
             <a:endParaRPr lang="en-US" dirty="0"/>
           </a:p>
@@ -1495,7 +1495,7 @@
           <a:p>
             <a:r>
               <a:rPr lang="en-US" dirty="0"/>
-              <a:t>Live: press Try this in a what-if, show the before and after table, then apply with a reason. The trace page shows both versions.</a:t>
+              <a:t>The second thing built this week is what-if and recheck. The officer edits a field, or presses "try this" on a proposal. The engine runs on a copy and shows each rule before and after: cleared, still flagged, or a new problem. Nothing is saved. Then, with a reason and a tick confirming the value was checked against the source, the correction is saved as version two, which goes through triage like any claim. Version one stays exactly as received and is closed, and the findings that were cleared are recorded with the reviewer's reason. The controls matter. Only the holder of the claim can try or apply a correction. Clearing a high-severity finding needs the same senior authority as deciding it, so correcting data cannot be a way around sign-off. Identifiers cannot be edited, and the reason may not contain them.</a:t>
             </a:r>
             <a:endParaRPr lang="en-US" dirty="0"/>
           </a:p>
@@ -1583,7 +1583,7 @@
           <a:p>
             <a:r>
               <a:rPr lang="en-US" dirty="0"/>
-              <a:t>The first version proposed only the line amount and created a new R012 failure in 25 of 30 cases, because the claim total had matched the wrong line. Measuring it found that; the copilot now proposes the line and the total together.</a:t>
+              <a:t>We measured the copilot against the real engine on the six hundred public claims. There are seven hundred seventy-seven flagged findings, each with exactly one suggestion. Of the proposed corrections, every one cleared the finding it was proposed for: thirty of thirty on line amounts, thirty-four of thirty-four on claim totals, twenty-nine of twenty-nine on currency. Applying all proposals on a claim created zero new findings, no cited path was missing from the claim, and no text had approval or payment words. Four thousand two hundred attempts to edit an identifier were all refused. The measurement also caught a real bug: the first version fixed the line amount alone and created a new total failure in twenty-five of thirty cases. The copilot now proposes the line and the total together. The limit is on the slide: only three rules have computable fixes, and the reviewer still checks the figure against the bill.</a:t>
             </a:r>
             <a:endParaRPr lang="en-US" dirty="0"/>
           </a:p>
@@ -1671,7 +1671,7 @@
           <a:p>
             <a:r>
               <a:rPr lang="en-US" dirty="0"/>
-              <a:t>Everything on this slide is simulated reviewers on the real pipeline. A timed session with real reviewers is the first thing to do next.</a:t>
+              <a:t>This slide is about making the operator's day easier, which is what you encouraged us to do beyond the minimum. There are four levers. Confirming needs no typed reason, because confirming agrees with the engine, while dismissing still needs one. Bulk confirm, auto-clear of green claims and auto-request of information are all off by default, each with a random audit sample and an exact bound on the miss rate. In simulation, the number of findings a person decides per five hundred claims dropped from six hundred fifty to three hundred ninety-nine, minus thirty-nine percent, with none wrong against the answer key. Everything here is simulated reviewers on the real pipeline. Time per finding has not been measured. The first real step is a timed session with a few officers, which is question four.</a:t>
             </a:r>
             <a:endParaRPr lang="en-US" dirty="0"/>
           </a:p>
@@ -1759,7 +1759,7 @@
           <a:p>
             <a:r>
               <a:rPr lang="en-US" dirty="0"/>
-              <a:t>He warned that a model trained on artificial decisions may only reproduce the rules. We tested that honestly and archived it.</a:t>
+              <a:t>You warned us that a model trained on artificial decisions might only reproduce the rules, so we tested that honestly. On the left is the workload report, which is live and read-only. It reads reviewer confirmations and dismissals per rule, and it lists rules reviewers keep overriding, which are candidates to retune, and rules almost always upheld, which are candidates for lighter review. In simulation it found both bad rules in twenty of twenty histories, with no false alarms. On the right is the fine-tuned model, Laya. It learned the rulebook: accuracy 0.97 against 0.63 zero-shot. But its labels are the engine's own, it finds only sixty-four percent of real failures, and it cannot save an operator time after the engine has run. So we archived it. It is not in the decision path, and a confidence is never shown as a probability.</a:t>
             </a:r>
             <a:endParaRPr lang="en-US" dirty="0"/>
           </a:p>
@@ -1847,7 +1847,7 @@
           <a:p>
             <a:r>
               <a:rPr lang="en-US" dirty="0"/>
-              <a:t>The rule logic follows published practice. The attributes the single-claim rules need are invented and labelled so.</a:t>
+              <a:t>These are the eight advisory rules, kept apart from the fifteen. They have their own ids, file and schema, and they never change an official result. E101 to E103 look across claims: a duplicate line, an authorization exhausted across claims, a daily quantity across claims. E102 is the cross-claim authorization usage you described, working on explicitly synthetic history, and it fires only when earlier claims contributed units, so it never double-reports what R009 already fails. E001 to E005 follow published practice on bundling, modifiers and diagnosis, but their attributes are invented and labelled so, which means they cannot fire on public data by design. Four thousand eight hundred of four thousand eight hundred results agree with an independent oracle.</a:t>
             </a:r>
             <a:endParaRPr lang="en-US" dirty="0"/>
           </a:p>
@@ -1935,7 +1935,7 @@
           <a:p>
             <a:r>
               <a:rPr lang="en-US" dirty="0"/>
-              <a:t>No outside party has attacked the system. Say so.</a:t>
+              <a:t>On security, four numbers. A hundred and sixteen black-box attack checks, all passing. Ninety-three deliberate breakages of the security and queue rules, each caught by a test. Four hundred thousand fuzzed requests through the API. And fifty checks on the deployment showing nothing but the proxy is reachable. Underneath: identity is badge, password and authenticator code, with four clearance levels enforced on the server, and a hidden action is not offered at all, not just disabled. Reviewers see pseudonyms, and unmasking needs its own permission, a reason, and an hourly limit. The most dangerous administrator actions need a second administrator. Claims, results and corrections are encrypted at rest. What is not done: nobody outside our team has attacked it, and one person holding two accounts is logged but not prevented.</a:t>
             </a:r>
             <a:endParaRPr lang="en-US" dirty="0"/>
           </a:p>
@@ -2023,7 +2023,7 @@
           <a:p>
             <a:r>
               <a:rPr lang="en-US" dirty="0"/>
-              <a:t>Run audit_guard_demo.py live: it rewrites a row and the health panel turns red.</a:t>
+              <a:t>Every important moment is written down. When a claim is received we record the input hash, the rule pack hash and the result hash. When a finding is decided, we record who, what, why, and the original status. A what-if is recorded with who and how many changes, and nothing else is kept. A saved correction links both versions by input hash and records each change from and to. Unmasking an identifier is recorded and counted against an hourly limit. On the right, the tamper evidence: logs are hash-chained and signed, an append-only mirror refuses to follow an edited log, and a ledger has checkpoints and Merkle proofs. In the demo I will rewrite an audit row, and the health panel goes red within seconds.</a:t>
             </a:r>
             <a:endParaRPr lang="en-US" dirty="0"/>
           </a:p>
@@ -2111,7 +2111,7 @@
           <a:p>
             <a:r>
               <a:rPr lang="en-US" dirty="0"/>
-              <a:t>Kubernetes manifests are written and structurally tested but there was no cluster to apply them to. Say so.</a:t>
+              <a:t>Everything runs on premises, because hospital data stays inside the hospital. I want to be precise about what has been tested and what has not. The Docker Compose stack with API, worker, MongoDB, Redis and proxy is tested: fifty of fifty attack checks and twenty-three of twenty-three backup and restore checks. Encrypted backup and restore have a runbook and were tested end to end. The model server is designed and scripted. Kubernetes manifests, network policies and restricted pods are written and tested structurally, but we had no cluster to apply them to. The firewall and outside port scan ran in throwaway containers, not on the real server, and the target server, an RTX 3080 with 10 gigabytes, has not been run on yet. For data protection, each obligation is mapped to what the system does. Subject access and erasure and a retention period are not built yet.</a:t>
             </a:r>
             <a:endParaRPr lang="en-US" dirty="0"/>
           </a:p>
@@ -2199,7 +2199,7 @@
           <a:p>
             <a:r>
               <a:rPr lang="en-US" dirty="0"/>
-              <a:t>Walk the table top to bottom. Points 4 and 6 contain questions for the mentor.</a:t>
+              <a:t>This slide is your email, point by point, with where we stand on each. One: human in the loop. Built, with lanes, a transparent score, four-eyes for high severity and a full audit trail. Two: all fifteen rules are right, with an F1 of 1.00 on the six hundred public claims, and the eight extra rules live in a separate pack so they never touch the benchmark. Three: the AI is grounded and has a plan for wrong output. Four: R006 stays exactly as documented, and I have three claims for you on the last slide. Five: authorization is aggregated per claim, and cross-claim is only an extension. Six: the wording is now pre-validation clearance, never approval. Seven: the JSONL schema is unchanged, with confidence null. Eight: one workflow, which is next.</a:t>
             </a:r>
             <a:endParaRPr lang="en-US" dirty="0"/>
           </a:p>
@@ -2287,7 +2287,7 @@
           <a:p>
             <a:r>
               <a:rPr lang="en-US" dirty="0"/>
-              <a:t>Measured on an RTX 4060 laptop with 8 GB, not the 3080 target. Ollama ran now. vLLM could not be installed here: the system drive has under 9 GB free and vLLM needs about 15 GB with a model.</a:t>
+              <a:t>This is what the model measured here. The laptop has an RTX 4060 with 8 gigabytes, not the 3080 target. With Ollama's default settings, it serves one request at a time: about fifty-three explanations a minute, at any concurrency. With eight parallel slots and flash attention, it reaches one hundred thirty-seven a minute, with no errors, and it stops improving past eight parallel requests. The better test is the one in the card below: three hundred ninety-nine claims through the real explanation step, with an empty cache. Seventy-four model calls answered seven hundred seventy-seven findings, and the run took forty-nine seconds, about four hundred ninety claims a minute. With a warm cache, about two thousand. So the model is not the limit. vLLM is the planned production server and has not been run here. We stay on Ollama unless the target measurement says otherwise, and the benchmark script works on either.</a:t>
             </a:r>
             <a:endParaRPr lang="en-US" dirty="0"/>
           </a:p>
@@ -2375,7 +2375,7 @@
           <a:p>
             <a:r>
               <a:rPr lang="en-US" dirty="0"/>
-              <a:t>Read this slide out. It is the most credible slide in the deck.</a:t>
+              <a:t>This is the most important slide for credibility, so I will read it. The public data is synthetic, so perfect scores do not show how real claims behave. The savings are simulated, and there has been no timed session with real reviewers. We have not run on the target server, so throughput on the RTX 3080 and vLLM are unmeasured. There is no Kubernetes cluster, so the manifests are only structurally tested. Real paper, handwriting and Arabic documents are untested. Subject access, erasure and retention are designed but not built. The copilot has computable fixes for three rules, and for the rest it asks or checks. And nobody outside the team has attacked the system. Each of these is a next step, not a hidden problem.</a:t>
             </a:r>
             <a:endParaRPr lang="en-US" dirty="0"/>
           </a:p>
@@ -2463,7 +2463,7 @@
           <a:p>
             <a:r>
               <a:rPr lang="en-US" dirty="0"/>
-              <a:t>Demo order follows the mentor's six steps.</a:t>
+              <a:t>For the demo, I will follow your six steps. A claim with a wrong amount arrives. The senior opens it and sees the summary and evidence. We try a what-if and every check would pass. We apply it with a reason, which creates version two. The trace shows both versions, who changed what and why. Then I rewrite an audit row and the alarm goes red. After that, four questions for you. First, R006 and R013: three public claims, CG-B10B19D8A56A, CG-00348A9B1AAD and CG-EC233ACB399D, split one service into a plain line and an EDU-SEPARATE line, and the rules pass them as documented, but the total quantity exceeds the per-line limit. Is that intended? Second, is pre-validation clear the right label? Third, is a Redis Streams queue in Rust acceptable in place of Celery or ARQ? Fourth, could we run a timed session with a few officers?</a:t>
             </a:r>
             <a:endParaRPr lang="en-US" dirty="0"/>
           </a:p>
@@ -2551,7 +2551,7 @@
           <a:p>
             <a:r>
               <a:rPr lang="en-US" dirty="0"/>
-              <a:t>Steps 3 and 5 are what was added this week. Everything else existed and was measured earlier.</a:t>
+              <a:t>This is the one workflow you asked for, in six steps. A claim arrives in any format and the fifteen rules run in under a fifth of a millisecond. Each finding is either a fail or unable-to-assess when data is missing, and it cites the claim paths it rests on. Third, the copilot explains it and says what to ask or correct, and it never invents a value. Fourth, the officer decides: confirm, dismiss with a reason, or request information, with a senior for high severity. Fifth, the officer corrects the claim and revalidates: a what-if first, then a new version, while the original stays untouched. Sixth, everything is traceable, with both versions side by side and the measured accuracy shown. Steps three and five are what we added this week, and they are marked in amber.</a:t>
             </a:r>
             <a:endParaRPr lang="en-US" dirty="0"/>
           </a:p>
@@ -2639,7 +2639,7 @@
           <a:p>
             <a:r>
               <a:rPr lang="en-US" dirty="0"/>
-              <a:t>Trace one claim left to right. MongoDB is the truth. Redis only carries work; losing it loses nothing because the outbox marker stays in MongoDB.</a:t>
+              <a:t>Here is how the pieces fit, and I will trace one claim from left to right. Inputs are validated at intake, and anything unreadable is quarantined with a reason. The rule engine writes the result to MongoDB, which is the source of truth: claims and results are encrypted at rest. A marker saying "publish this" is written in the same operation, and Redis Streams carries the work to a pool of consumers. The AI explanation step has a circuit breaker, a budget, a cache and a grounding guard. The dispatcher puts the claim in a personal inbox, the officer decides in the console, and a correction becomes a new version that goes through the same path again. Along the bottom are the records: signed logs, a ledger, and access control with pseudonymised identifiers. Redis only carries work. If we lose it, we lose nothing, because the marker stays in MongoDB.</a:t>
             </a:r>
             <a:endParaRPr lang="en-US" dirty="0"/>
           </a:p>
@@ -2727,7 +2727,7 @@
           <a:p>
             <a:r>
               <a:rPr lang="en-US" dirty="0"/>
-              <a:t>Be upfront: the public set is synthetic and small. Nine of fifteen rules have no failing example in the 50-claim split, which is why the 150 and 400 splits are reported beside it.</a:t>
+              <a:t>On correctness, I want to be upfront. The F1 is 1.00 on all six hundred public claims: four hundred development, a hundred and fifty validation and fifty stress. Zero of three thousand and fifteen clean results were wrongly flagged, and the ninety-five percent bound on the false-alarm rate is 1.9 percent. The Rust engine runs in 0.19 milliseconds per claim and agrees exactly with the Python reference on ten thousand six hundred claims. Missing data gives unable-to-assess, never a pass. R006 is exactly as documented, and R009 aggregates per authorization within one claim. The advisory rules are kept apart. The caveat is the one on the slide: the public set is synthetic, so a perfect score is not proof about real claims, and nine of fifteen rules have no failing example in the fifty-claim split.</a:t>
             </a:r>
             <a:endParaRPr lang="en-US" dirty="0"/>
           </a:p>
@@ -2815,7 +2815,7 @@
           <a:p>
             <a:r>
               <a:rPr lang="en-US" dirty="0"/>
-              <a:t>The document reader runs in its own container. Say plainly that handwriting and Arabic are untested.</a:t>
+              <a:t>Claims do not arrive tidy, so intake treats every file as untrusted until proven. FHIR bundles, CSV tables and JSONL give identical claims and identical reports on all six hundred public claims. Twelve thousand randomly damaged FHIR bundles reached the same accept-or-quarantine verdict as the reference. For PDFs and photos, the reader runs in its own isolated container. On two hundred and forty synthetic documents it read ninety-seven point four percent of fields correctly, with one silent error. A reading is only ever a draft, and the clerk compares every field with the page. I should say plainly that real paper, handwriting and Arabic are not tested yet. A damaged record is quarantined with a reason and never stops the run.</a:t>
             </a:r>
             <a:endParaRPr lang="en-US" dirty="0"/>
           </a:p>
@@ -2903,7 +2903,7 @@
           <a:p>
             <a:r>
               <a:rPr lang="en-US" dirty="0"/>
-              <a:t>You asked for Celery or ARQ. Those are Python libraries; this is the same pattern in Rust on Redis Streams. Question 2 in the mentor pack asks whether that is acceptable.</a:t>
+              <a:t>Now the task queue. You mentioned Celery or ARQ. Those are Python libraries, and what we built is the same pattern in Rust on Redis Streams, which is question three for you at the end. The flow: intake writes the claim and a publish marker in one atomic write. The relay publishes and clears the marker only after Redis accepted. A consumer group and a pool process the claims. Each of the six boxes below is a failure we designed for and tested. If Redis is down, the markers wait in MongoDB. If a consumer dies, another takes over its message. A poison claim becomes a dead letter after three deliveries. Duplicates change nothing. A burst waits in the stream, never in front of the model. A lost message is republished after fifteen minutes. Throughput on the target server is not measured yet.</a:t>
             </a:r>
             <a:endParaRPr lang="en-US" dirty="0"/>
           </a:p>
@@ -2991,7 +2991,7 @@
           <a:p>
             <a:r>
               <a:rPr lang="en-US" dirty="0"/>
-              <a:t>The people and the model in the simulation are simulated. The invariants (no claim in two inboxes, nobody decides a claim they may not) are what carries over.</a:t>
+              <a:t>This is how the work reaches people. Every flagged finding earns points: a fail on a high-severity rule counts four, down to one for a medium-severity unable-to-assess. Green means nothing flagged. Lane A is one to three flagged findings with a score under ten, and lane B is the rest. The score is deliberately simple and transparent, as you asked. High severity needs a senior, a different senior countersigns blind, and a third settles a disagreement. Leases return abandoned claims to the pool, and no route lets anyone assign or move a claim. The chart is a simulation with simulated people and a simulated clock: draining five hundred claims takes about three hours with four seniors, and nearly six with four-eyes. Two hundred and fifty-three of the five hundred need a senior, so seniors are the bottleneck.</a:t>
             </a:r>
             <a:endParaRPr lang="en-US" dirty="0"/>
           </a:p>
@@ -3079,7 +3079,7 @@
           <a:p>
             <a:r>
               <a:rPr lang="en-US" dirty="0"/>
-              <a:t>The cache holds text with placeholders. The grounding guard runs again on the filled text every time, cached or not.</a:t>
+              <a:t>The cache is the reason the model is not a bottleneck. What is cached is an explanation template: text with the placeholders value and line, keyed by the rule, the failure shape, the prompt version and the model. The model never sees a claim value, so the cached text can contain none. What is never cached: the filled text, the claim values, and anything about permissions. A demotion must apply at once. The grounding guard runs again on the filled text every time, cached or not. We measured this under load this week: three hundred ninety-nine claims with findings, seven hundred seventy-seven findings, the real engine and the real model. With an empty cache, ninety point five percent of findings needed no model call. Once warm, it is ninety-seven point seven. Five failures in a row open the breaker, and the hard deadline is ninety seconds.</a:t>
             </a:r>
             <a:endParaRPr lang="en-US" dirty="0"/>
           </a:p>
@@ -15896,7 +15896,7 @@
                             <a:srgbClr val="14746F"/>
                           </a:solidFill>
                         </a:rPr>
-                        <a:t>52.4</a:t>
+                        <a:t>53.3</a:t>
                       </a:r>
                       <a:endParaRPr lang="en-US" sz="1300" dirty="0"/>
                     </a:p>
@@ -15957,7 +15957,7 @@
                             <a:srgbClr val="17292B"/>
                           </a:solidFill>
                         </a:rPr>
-                        <a:t>1.16 s</a:t>
+                        <a:t>1.13 s</a:t>
                       </a:r>
                       <a:endParaRPr lang="en-US" sz="1300" dirty="0"/>
                     </a:p>
@@ -16018,7 +16018,7 @@
                             <a:srgbClr val="17292B"/>
                           </a:solidFill>
                         </a:rPr>
-                        <a:t>62.7</a:t>
+                        <a:t>63.8</a:t>
                       </a:r>
                       <a:endParaRPr lang="en-US" sz="1300" dirty="0"/>
                     </a:p>
@@ -16264,7 +16264,7 @@
                             <a:srgbClr val="14746F"/>
                           </a:solidFill>
                         </a:rPr>
-                        <a:t>116.6</a:t>
+                        <a:t>122.9</a:t>
                       </a:r>
                       <a:endParaRPr lang="en-US" sz="1300" dirty="0"/>
                     </a:p>
@@ -16325,7 +16325,7 @@
                             <a:srgbClr val="17292B"/>
                           </a:solidFill>
                         </a:rPr>
-                        <a:t>2 s</a:t>
+                        <a:t>1.79 s</a:t>
                       </a:r>
                       <a:endParaRPr lang="en-US" sz="1300" dirty="0"/>
                     </a:p>
@@ -16386,7 +16386,7 @@
                             <a:srgbClr val="17292B"/>
                           </a:solidFill>
                         </a:rPr>
-                        <a:t>139.9</a:t>
+                        <a:t>146.5</a:t>
                       </a:r>
                       <a:endParaRPr lang="en-US" sz="1300" dirty="0"/>
                     </a:p>
@@ -16632,7 +16632,7 @@
                             <a:srgbClr val="14746F"/>
                           </a:solidFill>
                         </a:rPr>
-                        <a:t>142.7</a:t>
+                        <a:t>137.5</a:t>
                       </a:r>
                       <a:endParaRPr lang="en-US" sz="1300" dirty="0"/>
                     </a:p>
@@ -16693,7 +16693,7 @@
                             <a:srgbClr val="17292B"/>
                           </a:solidFill>
                         </a:rPr>
-                        <a:t>3.16 s</a:t>
+                        <a:t>3.26 s</a:t>
                       </a:r>
                       <a:endParaRPr lang="en-US" sz="1300" dirty="0"/>
                     </a:p>
@@ -16754,7 +16754,7 @@
                             <a:srgbClr val="17292B"/>
                           </a:solidFill>
                         </a:rPr>
-                        <a:t>171</a:t>
+                        <a:t>165.3</a:t>
                       </a:r>
                       <a:endParaRPr lang="en-US" sz="1300" dirty="0"/>
                     </a:p>
@@ -17000,7 +17000,7 @@
                             <a:srgbClr val="14746F"/>
                           </a:solidFill>
                         </a:rPr>
-                        <a:t>131.9</a:t>
+                        <a:t>134.9</a:t>
                       </a:r>
                       <a:endParaRPr lang="en-US" sz="1300" dirty="0"/>
                     </a:p>
@@ -17061,7 +17061,7 @@
                             <a:srgbClr val="17292B"/>
                           </a:solidFill>
                         </a:rPr>
-                        <a:t>6.79 s</a:t>
+                        <a:t>6.75 s</a:t>
                       </a:r>
                       <a:endParaRPr lang="en-US" sz="1300" dirty="0"/>
                     </a:p>
@@ -17122,7 +17122,7 @@
                             <a:srgbClr val="17292B"/>
                           </a:solidFill>
                         </a:rPr>
-                        <a:t>158.9</a:t>
+                        <a:t>160.4</a:t>
                       </a:r>
                       <a:endParaRPr lang="en-US" sz="1300" dirty="0"/>
                     </a:p>
@@ -17207,7 +17207,7 @@
                 <a:ea typeface="Cambria" pitchFamily="34" charset="-122"/>
                 <a:cs typeface="Cambria" pitchFamily="34" charset="-120"/>
               </a:rPr>
-              <a:t>143</a:t>
+              <a:t>137</a:t>
             </a:r>
             <a:endParaRPr lang="en-US" sz="5400" dirty="0"/>
           </a:p>
@@ -17243,7 +17243,7 @@
                   <a:srgbClr val="5C7173"/>
                 </a:solidFill>
               </a:rPr>
-              <a:t>explanations a minute with 8 slots (gemma3:4b, laptop RTX 4060). Default: 54, one at a time</a:t>
+              <a:t>explanations a minute with 8 slots (gemma3:4b, laptop RTX 4060). Default: 53, one at a time</a:t>
             </a:r>
             <a:endParaRPr lang="en-US" sz="1400" dirty="0"/>
           </a:p>
@@ -17309,7 +17309,7 @@
                   <a:srgbClr val="0E3B3F"/>
                 </a:solidFill>
               </a:rPr>
-              <a:t>vLLM is the planned production server, and it has not been run.</a:t>
+              <a:t>Through the real queue step: 399 claims, 777 findings, empty cache, 8 workers.</a:t>
             </a:r>
             <a:endParaRPr lang="en-US" sz="1400" dirty="0"/>
           </a:p>
@@ -17323,7 +17323,7 @@
                   <a:srgbClr val="17292B"/>
                 </a:solidFill>
               </a:rPr>
-              <a:t>Ollama's downloaded model cannot be reused by vLLM, the Hugging Face cache holds no chat model, and the laptop's system drive has under 9 GB free (vLLM with a 4B model needs about 15 GB). Only 5% of findings need a model call once the template cache is warm, so 140 calls a minute can cover roughly 2,800 findings a minute. The benchmark script works against any server, so the same table can be made on the target.</a:t>
+              <a:t>74 model calls (90.5% of findings needed none), 49 seconds, about 490 claims a minute; warm cache about 2,050 a minute, 18 calls that retried 3 templates the guard had refused. 0 model errors. A debug build on this laptop, not the target card. vLLM is the planned production server and has not been run here: we stay on Ollama unless the target measurement says otherwise, and the benchmark script works on either.</a:t>
             </a:r>
             <a:endParaRPr lang="en-US" sz="1400" dirty="0"/>
           </a:p>
@@ -27006,7 +27006,7 @@
               <a:buNone/>
             </a:pPr>
             <a:r>
-              <a:rPr lang="en-US" sz="3200" b="1" dirty="0">
+              <a:rPr lang="en-US" sz="3000" b="1" dirty="0">
                 <a:solidFill>
                   <a:srgbClr val="14746F"/>
                 </a:solidFill>
@@ -27014,9 +27014,9 @@
                 <a:ea typeface="Cambria" pitchFamily="34" charset="-122"/>
                 <a:cs typeface="Cambria" pitchFamily="34" charset="-120"/>
               </a:rPr>
-              <a:t>632 of 665</a:t>
-            </a:r>
-            <a:endParaRPr lang="en-US" sz="3200" dirty="0"/>
+              <a:t>90.5% to 97.7%</a:t>
+            </a:r>
+            <a:endParaRPr lang="en-US" sz="3000" dirty="0"/>
           </a:p>
         </p:txBody>
       </p:sp>
@@ -27050,7 +27050,7 @@
                   <a:srgbClr val="5C7173"/>
                 </a:solidFill>
               </a:rPr>
-              <a:t>findings served from the template cache (95%), 33 model calls</a:t>
+              <a:t>of 777 findings need no model call: empty cache, then warm (real model, 399 claims)</a:t>
             </a:r>
             <a:endParaRPr lang="en-US" sz="1400" dirty="0"/>
           </a:p>
@@ -27236,7 +27236,7 @@
                   <a:srgbClr val="5C7173"/>
                 </a:solidFill>
               </a:rPr>
-              <a:t>Budgets (explanations per minute and per day) are counted in the database, not in Redis. Defaults: 30 a minute, 2,000 a day.</a:t>
+              <a:t>Budgets are counted in the database, not Redis (defaults 30 a minute, 2,000 a day; the load test raised the minute budget to 600). A template the guard refuses is not cached.</a:t>
             </a:r>
             <a:endParaRPr lang="en-US" sz="1100" dirty="0"/>
           </a:p>

</xml_diff>